<commit_message>
Atualiza slides da Aula 01 (CEA055) e adiciona script de sincronizacao
Novo scripts/atualizar_slides.py detecta, por data de modificacao,
slides revisados na pasta-fonte (fonte_slides em _disciplina.yaml) e
ainda nao publicados; reconverte para PDF via LibreOffice, copia para
content/ e reconstroi o site. Usado agora para publicar a revisao da
Aula 01.
</commit_message>
<xml_diff>
--- a/content/2026-2/cea055-estatistica-probabilidade/01-estatistica-descritiva-i/Aula_01_Estatistica_Descritiva_I.pptx
+++ b/content/2026-2/cea055-estatistica-probabilidade/01-estatistica-descritiva-i/Aula_01_Estatistica_Descritiva_I.pptx
@@ -5,7 +5,7 @@
     <p:sldMasterId id="2147483648" r:id="rId1"/>
   </p:sldMasterIdLst>
   <p:notesMasterIdLst>
-    <p:notesMasterId r:id="rId28"/>
+    <p:notesMasterId r:id="rId33"/>
   </p:notesMasterIdLst>
   <p:sldIdLst>
     <p:sldId id="257" r:id="rId2"/>
@@ -34,11 +34,11 @@
     <p:sldId id="303" r:id="rId25"/>
     <p:sldId id="288" r:id="rId26"/>
     <p:sldId id="266" r:id="rId27"/>
-    <p:sldId id="305" r:id="rId34"/>
-    <p:sldId id="306" r:id="rId35"/>
-    <p:sldId id="307" r:id="rId36"/>
-    <p:sldId id="308" r:id="rId37"/>
-    <p:sldId id="304" r:id="rId33"/>
+    <p:sldId id="305" r:id="rId28"/>
+    <p:sldId id="306" r:id="rId29"/>
+    <p:sldId id="307" r:id="rId30"/>
+    <p:sldId id="308" r:id="rId31"/>
+    <p:sldId id="304" r:id="rId32"/>
   </p:sldIdLst>
   <p:sldSz cx="12192000" cy="6858000"/>
   <p:notesSz cx="6858000" cy="9144000"/>
@@ -241,7 +241,7 @@
           <a:p>
             <a:fld id="{44623A65-BD25-40B6-8815-498297225DF7}" type="datetimeFigureOut">
               <a:rPr lang="pt-BR" smtClean="0"/>
-              <a:t>25/03/2024</a:t>
+              <a:t>30/07/2026</a:t>
             </a:fld>
             <a:endParaRPr lang="pt-BR" dirty="0"/>
           </a:p>
@@ -744,7 +744,7 @@
           <a:p>
             <a:fld id="{5B45E566-B383-4B2D-B951-1136FD38326E}" type="datetimeFigureOut">
               <a:rPr lang="pt-BR" smtClean="0"/>
-              <a:t>25/03/2024</a:t>
+              <a:t>30/07/2026</a:t>
             </a:fld>
             <a:endParaRPr lang="pt-BR" dirty="0"/>
           </a:p>
@@ -942,7 +942,7 @@
           <a:p>
             <a:fld id="{5B45E566-B383-4B2D-B951-1136FD38326E}" type="datetimeFigureOut">
               <a:rPr lang="pt-BR" smtClean="0"/>
-              <a:t>25/03/2024</a:t>
+              <a:t>30/07/2026</a:t>
             </a:fld>
             <a:endParaRPr lang="pt-BR" dirty="0"/>
           </a:p>
@@ -1150,7 +1150,7 @@
           <a:p>
             <a:fld id="{5B45E566-B383-4B2D-B951-1136FD38326E}" type="datetimeFigureOut">
               <a:rPr lang="pt-BR" smtClean="0"/>
-              <a:t>25/03/2024</a:t>
+              <a:t>30/07/2026</a:t>
             </a:fld>
             <a:endParaRPr lang="pt-BR" dirty="0"/>
           </a:p>
@@ -1348,7 +1348,7 @@
           <a:p>
             <a:fld id="{5B45E566-B383-4B2D-B951-1136FD38326E}" type="datetimeFigureOut">
               <a:rPr lang="pt-BR" smtClean="0"/>
-              <a:t>25/03/2024</a:t>
+              <a:t>30/07/2026</a:t>
             </a:fld>
             <a:endParaRPr lang="pt-BR" dirty="0"/>
           </a:p>
@@ -1623,7 +1623,7 @@
           <a:p>
             <a:fld id="{5B45E566-B383-4B2D-B951-1136FD38326E}" type="datetimeFigureOut">
               <a:rPr lang="pt-BR" smtClean="0"/>
-              <a:t>25/03/2024</a:t>
+              <a:t>30/07/2026</a:t>
             </a:fld>
             <a:endParaRPr lang="pt-BR" dirty="0"/>
           </a:p>
@@ -1888,7 +1888,7 @@
           <a:p>
             <a:fld id="{5B45E566-B383-4B2D-B951-1136FD38326E}" type="datetimeFigureOut">
               <a:rPr lang="pt-BR" smtClean="0"/>
-              <a:t>25/03/2024</a:t>
+              <a:t>30/07/2026</a:t>
             </a:fld>
             <a:endParaRPr lang="pt-BR" dirty="0"/>
           </a:p>
@@ -2300,7 +2300,7 @@
           <a:p>
             <a:fld id="{5B45E566-B383-4B2D-B951-1136FD38326E}" type="datetimeFigureOut">
               <a:rPr lang="pt-BR" smtClean="0"/>
-              <a:t>25/03/2024</a:t>
+              <a:t>30/07/2026</a:t>
             </a:fld>
             <a:endParaRPr lang="pt-BR" dirty="0"/>
           </a:p>
@@ -2441,7 +2441,7 @@
           <a:p>
             <a:fld id="{5B45E566-B383-4B2D-B951-1136FD38326E}" type="datetimeFigureOut">
               <a:rPr lang="pt-BR" smtClean="0"/>
-              <a:t>25/03/2024</a:t>
+              <a:t>30/07/2026</a:t>
             </a:fld>
             <a:endParaRPr lang="pt-BR" dirty="0"/>
           </a:p>
@@ -2554,7 +2554,7 @@
           <a:p>
             <a:fld id="{5B45E566-B383-4B2D-B951-1136FD38326E}" type="datetimeFigureOut">
               <a:rPr lang="pt-BR" smtClean="0"/>
-              <a:t>25/03/2024</a:t>
+              <a:t>30/07/2026</a:t>
             </a:fld>
             <a:endParaRPr lang="pt-BR" dirty="0"/>
           </a:p>
@@ -2865,7 +2865,7 @@
           <a:p>
             <a:fld id="{5B45E566-B383-4B2D-B951-1136FD38326E}" type="datetimeFigureOut">
               <a:rPr lang="pt-BR" smtClean="0"/>
-              <a:t>25/03/2024</a:t>
+              <a:t>30/07/2026</a:t>
             </a:fld>
             <a:endParaRPr lang="pt-BR" dirty="0"/>
           </a:p>
@@ -3153,7 +3153,7 @@
           <a:p>
             <a:fld id="{5B45E566-B383-4B2D-B951-1136FD38326E}" type="datetimeFigureOut">
               <a:rPr lang="pt-BR" smtClean="0"/>
-              <a:t>25/03/2024</a:t>
+              <a:t>30/07/2026</a:t>
             </a:fld>
             <a:endParaRPr lang="pt-BR" dirty="0"/>
           </a:p>
@@ -3418,7 +3418,7 @@
           <a:p>
             <a:fld id="{5B45E566-B383-4B2D-B951-1136FD38326E}" type="datetimeFigureOut">
               <a:rPr lang="pt-BR" smtClean="0"/>
-              <a:t>25/03/2024</a:t>
+              <a:t>30/07/2026</a:t>
             </a:fld>
             <a:endParaRPr lang="pt-BR" dirty="0"/>
           </a:p>
@@ -3899,8 +3899,8 @@
         </p:nvSpPr>
         <p:spPr>
           <a:xfrm>
-            <a:off x="1032608" y="1941868"/>
-            <a:ext cx="10067277" cy="3693411"/>
+            <a:off x="986225" y="1498668"/>
+            <a:ext cx="10067277" cy="4555093"/>
           </a:xfrm>
           <a:prstGeom prst="rect">
             <a:avLst/>
@@ -3914,7 +3914,7 @@
           <a:lstStyle/>
           <a:p>
             <a:r>
-              <a:rPr lang="pt-BR" sz="2400" b="1" dirty="0"/>
+              <a:rPr lang="pt-BR" sz="2800" b="1" dirty="0"/>
               <a:t>Objetivos do aula:</a:t>
             </a:r>
           </a:p>
@@ -3924,7 +3924,7 @@
               <a:buChar char="•"/>
             </a:pPr>
             <a:r>
-              <a:rPr lang="pt-BR" sz="2400" dirty="0"/>
+              <a:rPr lang="pt-BR" sz="2600" dirty="0"/>
               <a:t>Conhecer os tipos de variáveis e algumas representações gráficas.</a:t>
             </a:r>
           </a:p>
@@ -3934,14 +3934,21 @@
               <a:buChar char="•"/>
             </a:pPr>
             <a:r>
-              <a:rPr lang="pt-BR" sz="2400" dirty="0"/>
+              <a:rPr lang="pt-BR" sz="2600" dirty="0"/>
               <a:t>Calcular e interpretar as medidas de posição (média, mediana e moda).</a:t>
             </a:r>
           </a:p>
           <a:p>
-            <a:r>
-              <a:rPr lang="pt-BR" sz="2400" b="1" dirty="0"/>
-              <a:t xml:space="preserve">Referências: </a:t>
+            <a:pPr marL="285737" indent="-285737">
+              <a:buFont typeface="Arial" panose="020B0604020202020204" pitchFamily="34" charset="0"/>
+              <a:buChar char="•"/>
+            </a:pPr>
+            <a:endParaRPr lang="pt-BR" sz="2600" dirty="0"/>
+          </a:p>
+          <a:p>
+            <a:r>
+              <a:rPr lang="pt-BR" sz="2800" b="1" dirty="0"/>
+              <a:t>Referências: </a:t>
             </a:r>
           </a:p>
           <a:p>
@@ -3950,15 +3957,15 @@
               <a:buChar char="•"/>
             </a:pPr>
             <a:r>
-              <a:rPr lang="pt-BR" sz="2000" dirty="0"/>
-              <a:t xml:space="preserve">Bussab, Morettin. </a:t>
-            </a:r>
-            <a:r>
-              <a:rPr lang="pt-BR" sz="2000" b="1" dirty="0"/>
+              <a:rPr lang="pt-BR" sz="2600" dirty="0"/>
+              <a:t>Bussab, Morettin. </a:t>
+            </a:r>
+            <a:r>
+              <a:rPr lang="pt-BR" sz="2600" b="1" dirty="0"/>
               <a:t>Estatística Básica</a:t>
             </a:r>
             <a:r>
-              <a:rPr lang="pt-BR" sz="2000" dirty="0"/>
+              <a:rPr lang="pt-BR" sz="2600" dirty="0"/>
               <a:t>, 9ed — Cap. 2 (2.1 a 2.4) e Cap. 3 (3.1)</a:t>
             </a:r>
           </a:p>
@@ -3968,15 +3975,15 @@
               <a:buChar char="•"/>
             </a:pPr>
             <a:r>
-              <a:rPr lang="pt-BR" sz="2000" dirty="0"/>
-              <a:t xml:space="preserve">Montgomery, Runger. </a:t>
-            </a:r>
-            <a:r>
-              <a:rPr lang="pt-BR" sz="2000" b="1" dirty="0"/>
+              <a:rPr lang="pt-BR" sz="2600" dirty="0"/>
+              <a:t>Montgomery, Runger. </a:t>
+            </a:r>
+            <a:r>
+              <a:rPr lang="pt-BR" sz="2600" b="1" dirty="0"/>
               <a:t>Applied Statistics and Probability for Engineers</a:t>
             </a:r>
             <a:r>
-              <a:rPr lang="pt-BR" sz="2000" dirty="0"/>
+              <a:rPr lang="pt-BR" sz="2600" dirty="0"/>
               <a:t>, 7th ed — Cap. 6 (6.1 a 6.3)</a:t>
             </a:r>
           </a:p>
@@ -3986,15 +3993,15 @@
               <a:buChar char="•"/>
             </a:pPr>
             <a:r>
-              <a:rPr lang="pt-BR" sz="2000" dirty="0"/>
-              <a:t xml:space="preserve">Magalhães, Lima. </a:t>
-            </a:r>
-            <a:r>
-              <a:rPr lang="pt-BR" sz="2000" b="1" dirty="0"/>
+              <a:rPr lang="pt-BR" sz="2600" dirty="0"/>
+              <a:t>Magalhães, Lima. </a:t>
+            </a:r>
+            <a:r>
+              <a:rPr lang="pt-BR" sz="2600" b="1" dirty="0"/>
               <a:t>Noções de Probabilidade e Estatística</a:t>
             </a:r>
             <a:r>
-              <a:rPr lang="pt-BR" sz="2000" dirty="0"/>
+              <a:rPr lang="pt-BR" sz="2600" dirty="0"/>
               <a:t>, 5ed — Cap. 1 (1.2)</a:t>
             </a:r>
           </a:p>
@@ -4447,7 +4454,7 @@
           <a:p>
             <a:r>
               <a:rPr lang="pt-BR" sz="2800" dirty="0"/>
-              <a:t xml:space="preserve">Usamos representações gráficas para melhorar a visualização da  distribuição (ou comportamento) de uma variável. </a:t>
+              <a:t>Usamos representações gráficas para melhorar a visualização da  distribuição (ou comportamento) de uma variável. </a:t>
             </a:r>
           </a:p>
           <a:p>
@@ -5382,8 +5389,12 @@
                 <a:endParaRPr lang="pt-BR" sz="2800" b="1" dirty="0"/>
               </a:p>
               <a:p>
+                <a:pPr marL="457200" indent="-457200">
+                  <a:buFont typeface="Arial" panose="020B0604020202020204" pitchFamily="34" charset="0"/>
+                  <a:buChar char="•"/>
+                </a:pPr>
                 <a:r>
-                  <a:rPr lang="pt-BR" sz="2800" b="1" dirty="0"/>
+                  <a:rPr lang="pt-BR" sz="2800" dirty="0"/>
                   <a:t>Histograma</a:t>
                 </a:r>
               </a:p>
@@ -5423,7 +5434,7 @@
                 </a:pPr>
                 <a:r>
                   <a:rPr lang="pt-BR" sz="2800" dirty="0"/>
-                  <a:t xml:space="preserve">Se a base do intervalo </a:t>
+                  <a:t>Se a base do intervalo </a:t>
                 </a:r>
                 <a14:m>
                   <m:oMath xmlns:m="http://schemas.openxmlformats.org/officeDocument/2006/math">
@@ -5437,7 +5448,7 @@
                 </a14:m>
                 <a:r>
                   <a:rPr lang="pt-BR" sz="2800" dirty="0"/>
-                  <a:t xml:space="preserve"> é denotada por </a:t>
+                  <a:t> é denotada por </a:t>
                 </a:r>
                 <a14:m>
                   <m:oMath xmlns:m="http://schemas.openxmlformats.org/officeDocument/2006/math">
@@ -5473,7 +5484,7 @@
                 </a14:m>
                 <a:r>
                   <a:rPr lang="pt-BR" sz="2800" dirty="0"/>
-                  <a:t xml:space="preserve">, então a altura do retângulo correspondente é proporcional a </a:t>
+                  <a:t>, então a altura do retângulo correspondente é proporcional a </a:t>
                 </a:r>
                 <a14:m>
                   <m:oMath xmlns:m="http://schemas.openxmlformats.org/officeDocument/2006/math">
@@ -6262,8 +6273,12 @@
             <a:endParaRPr lang="pt-BR" sz="2800" b="1" dirty="0"/>
           </a:p>
           <a:p>
-            <a:r>
-              <a:rPr lang="pt-BR" sz="2800" b="1" dirty="0"/>
+            <a:pPr marL="457200" indent="-457200">
+              <a:buFont typeface="Arial" panose="020B0604020202020204" pitchFamily="34" charset="0"/>
+              <a:buChar char="•"/>
+            </a:pPr>
+            <a:r>
+              <a:rPr lang="pt-BR" sz="2800" dirty="0"/>
               <a:t>Ramo-e-folhas</a:t>
             </a:r>
           </a:p>
@@ -6684,7 +6699,7 @@
         <p:spPr>
           <a:xfrm>
             <a:off x="650240" y="1493523"/>
-            <a:ext cx="11180365" cy="4401205"/>
+            <a:ext cx="11180365" cy="4616648"/>
           </a:xfrm>
           <a:prstGeom prst="rect">
             <a:avLst/>
@@ -6699,7 +6714,7 @@
           <a:p>
             <a:r>
               <a:rPr lang="pt-BR" sz="2800" dirty="0"/>
-              <a:t xml:space="preserve">Vamos introduzir o conceito de </a:t>
+              <a:t>Vamos introduzir o conceito de </a:t>
             </a:r>
             <a:r>
               <a:rPr lang="pt-BR" sz="2800" b="1" dirty="0"/>
@@ -6707,19 +6722,21 @@
             </a:r>
             <a:r>
               <a:rPr lang="pt-BR" sz="2800" dirty="0"/>
-              <a:t xml:space="preserve"> com um exemplo:</a:t>
+              <a:t> com um exemplo:</a:t>
             </a:r>
           </a:p>
           <a:p>
             <a:endParaRPr lang="pt-BR" sz="2800" b="1" dirty="0"/>
           </a:p>
           <a:p>
-            <a:endParaRPr lang="pt-BR" sz="2800" b="1" dirty="0"/>
-          </a:p>
-          <a:p>
+            <a:pPr>
+              <a:lnSpc>
+                <a:spcPct val="150000"/>
+              </a:lnSpc>
+            </a:pPr>
             <a:r>
               <a:rPr lang="pt-BR" sz="2800" b="1" dirty="0"/>
-              <a:t xml:space="preserve">Exemplo: </a:t>
+              <a:t>Exemplo: </a:t>
             </a:r>
             <a:r>
               <a:rPr lang="pt-BR" sz="2800" dirty="0"/>
@@ -6727,13 +6744,15 @@
             </a:r>
           </a:p>
           <a:p>
+            <a:pPr>
+              <a:lnSpc>
+                <a:spcPct val="150000"/>
+              </a:lnSpc>
+            </a:pPr>
             <a:r>
               <a:rPr lang="pt-BR" sz="2800" dirty="0"/>
               <a:t>chamada planilha de dados.</a:t>
             </a:r>
-          </a:p>
-          <a:p>
-            <a:endParaRPr lang="pt-BR" sz="2800" dirty="0"/>
           </a:p>
           <a:p>
             <a:pPr algn="ctr"/>
@@ -8424,7 +8443,7 @@
             </a:pPr>
             <a:r>
               <a:rPr lang="pt-BR" sz="2800" dirty="0"/>
-              <a:t xml:space="preserve">Exercícios 1 ao 8 do capítulo 2. </a:t>
+              <a:t>Exercícios 1 ao 8 do capítulo 2. </a:t>
             </a:r>
           </a:p>
           <a:p>
@@ -8646,7 +8665,7 @@
             </a:pPr>
             <a:r>
               <a:rPr lang="pt-BR" sz="2800" b="1" dirty="0"/>
-              <a:t xml:space="preserve">Moda: </a:t>
+              <a:t>Moda: </a:t>
             </a:r>
             <a:r>
               <a:rPr lang="pt-BR" sz="2800" dirty="0"/>
@@ -8667,11 +8686,11 @@
             </a:pPr>
             <a:r>
               <a:rPr lang="pt-BR" sz="2800" b="1" dirty="0"/>
-              <a:t xml:space="preserve">Mediana: </a:t>
+              <a:t>Mediana: </a:t>
             </a:r>
             <a:r>
               <a:rPr lang="pt-BR" sz="2800" dirty="0"/>
-              <a:t xml:space="preserve">é a realização que ocupa a posição central da série (ordenada) de observações. </a:t>
+              <a:t>é a realização que ocupa a posição central da série (ordenada) de observações. </a:t>
             </a:r>
           </a:p>
           <a:p>
@@ -8688,7 +8707,7 @@
             </a:pPr>
             <a:r>
               <a:rPr lang="pt-BR" sz="2800" b="1" dirty="0"/>
-              <a:t xml:space="preserve">Média (média aritmética): </a:t>
+              <a:t>Média (média aritmética): </a:t>
             </a:r>
             <a:r>
               <a:rPr lang="pt-BR" sz="2800" dirty="0"/>
@@ -8885,11 +8904,11 @@
               <a:p>
                 <a:r>
                   <a:rPr lang="pt-BR" sz="2800" b="1" dirty="0"/>
-                  <a:t xml:space="preserve">Exemplo: </a:t>
+                  <a:t>Exemplo: </a:t>
                 </a:r>
                 <a:r>
                   <a:rPr lang="pt-BR" sz="2800" dirty="0"/>
-                  <a:t xml:space="preserve">Considere o conjunto de dados </a:t>
+                  <a:t>Considere o conjunto de dados </a:t>
                 </a:r>
                 <a14:m>
                   <m:oMath xmlns:m="http://schemas.openxmlformats.org/officeDocument/2006/math">
@@ -9197,7 +9216,7 @@
               <a:p>
                 <a:r>
                   <a:rPr lang="pt-BR" sz="2800" dirty="0"/>
-                  <a:t xml:space="preserve">Sejam </a:t>
+                  <a:t>Sejam </a:t>
                 </a:r>
                 <a14:m>
                   <m:oMath xmlns:m="http://schemas.openxmlformats.org/officeDocument/2006/math">
@@ -9305,7 +9324,7 @@
                 </a14:m>
                 <a:r>
                   <a:rPr lang="pt-BR" sz="2800" dirty="0"/>
-                  <a:t xml:space="preserve"> um conjunto de dados (distintos ou não).</a:t>
+                  <a:t> um conjunto de dados (distintos ou não).</a:t>
                 </a:r>
               </a:p>
               <a:p>
@@ -9322,7 +9341,7 @@
                 </a:pPr>
                 <a:r>
                   <a:rPr lang="pt-BR" sz="2800" b="1" dirty="0"/>
-                  <a:t xml:space="preserve">Média: </a:t>
+                  <a:t>Média: </a:t>
                 </a:r>
                 <a:endParaRPr lang="pt-BR" sz="2800" b="1" i="1" dirty="0">
                   <a:latin typeface="Cambria Math" panose="02040503050406030204" pitchFamily="18" charset="0"/>
@@ -10451,8 +10470,8 @@
           </a:xfrm>
         </p:spPr>
       </p:pic>
-      <mc:AlternateContent xmlns:mc="http://schemas.openxmlformats.org/markup-compatibility/2006">
-        <mc:Choice xmlns:a14="http://schemas.microsoft.com/office/drawing/2010/main" Requires="a14">
+      <mc:AlternateContent xmlns:mc="http://schemas.openxmlformats.org/markup-compatibility/2006" xmlns:a14="http://schemas.microsoft.com/office/drawing/2010/main">
+        <mc:Choice Requires="a14">
           <p:sp>
             <p:nvSpPr>
               <p:cNvPr id="6" name="CaixaDeTexto 5">
@@ -10487,13 +10506,13 @@
                 </a:pPr>
                 <a:r>
                   <a:rPr lang="pt-BR" sz="2800" b="1" dirty="0"/>
-                  <a:t xml:space="preserve">Mediana: </a:t>
+                  <a:t>Mediana: </a:t>
                 </a:r>
               </a:p>
               <a:p>
                 <a:r>
                   <a:rPr lang="pt-BR" sz="2800" dirty="0"/>
-                  <a:t xml:space="preserve">Considere o conjunto de dados </a:t>
+                  <a:t>Considere o conjunto de dados </a:t>
                 </a:r>
                 <a14:m>
                   <m:oMath xmlns:m="http://schemas.openxmlformats.org/officeDocument/2006/math">
@@ -10616,7 +10635,7 @@
                 </a14:m>
                 <a:r>
                   <a:rPr lang="pt-BR" sz="2800" dirty="0"/>
-                  <a:t xml:space="preserve"> e ordene os dados de forma crescente:</a:t>
+                  <a:t> e ordene os dados de forma crescente:</a:t>
                 </a:r>
               </a:p>
               <a:p>
@@ -10794,7 +10813,7 @@
                 </a:pPr>
                 <a:r>
                   <a:rPr lang="pt-BR" sz="2800" dirty="0"/>
-                  <a:t xml:space="preserve">Se </a:t>
+                  <a:t>Se </a:t>
                 </a:r>
                 <a14:m>
                   <m:oMath xmlns:m="http://schemas.openxmlformats.org/officeDocument/2006/math">
@@ -10808,7 +10827,7 @@
                 </a14:m>
                 <a:r>
                   <a:rPr lang="pt-BR" sz="2800" dirty="0"/>
-                  <a:t xml:space="preserve"> é par, </a:t>
+                  <a:t> é par, </a:t>
                 </a:r>
                 <a14:m>
                   <m:oMath xmlns:m="http://schemas.openxmlformats.org/officeDocument/2006/math">
@@ -11013,7 +11032,7 @@
                 </a:pPr>
                 <a:r>
                   <a:rPr lang="pt-BR" sz="2800" dirty="0"/>
-                  <a:t xml:space="preserve">Se </a:t>
+                  <a:t>Se </a:t>
                 </a:r>
                 <a14:m>
                   <m:oMath xmlns:m="http://schemas.openxmlformats.org/officeDocument/2006/math">
@@ -11027,7 +11046,7 @@
                 </a14:m>
                 <a:r>
                   <a:rPr lang="pt-BR" sz="2800" dirty="0"/>
-                  <a:t xml:space="preserve"> é ímpar, </a:t>
+                  <a:t> é ímpar, </a:t>
                 </a:r>
                 <a14:m>
                   <m:oMath xmlns:m="http://schemas.openxmlformats.org/officeDocument/2006/math">
@@ -11130,7 +11149,7 @@
             </p:txBody>
           </p:sp>
         </mc:Choice>
-        <mc:Fallback>
+        <mc:Fallback xmlns="">
           <p:sp>
             <p:nvSpPr>
               <p:cNvPr id="6" name="CaixaDeTexto 5">
@@ -11307,7 +11326,7 @@
           </p:nvPr>
         </p:nvPicPr>
         <p:blipFill>
-          <a:blip r:embed="rId3">
+          <a:blip r:embed="rId2">
             <a:extLst>
               <a:ext uri="{28A0092B-C50C-407E-A947-70E740481C1C}">
                 <a14:useLocalDpi xmlns:a14="http://schemas.microsoft.com/office/drawing/2010/main" val="0"/>
@@ -11339,8 +11358,8 @@
         </p:nvSpPr>
         <p:spPr>
           <a:xfrm>
-            <a:off x="1032611" y="1941869"/>
-            <a:ext cx="10827959" cy="4501205"/>
+            <a:off x="1125377" y="1780477"/>
+            <a:ext cx="10827959" cy="4568943"/>
           </a:xfrm>
           <a:prstGeom prst="rect">
             <a:avLst/>
@@ -11359,6 +11378,11 @@
             </a:r>
           </a:p>
           <a:p>
+            <a:pPr>
+              <a:lnSpc>
+                <a:spcPct val="150000"/>
+              </a:lnSpc>
+            </a:pPr>
             <a:r>
               <a:rPr lang="pt-BR" sz="2000" dirty="0"/>
               <a:t>Leitura recomendada:</a:t>
@@ -11366,6 +11390,9 @@
           </a:p>
           <a:p>
             <a:pPr marL="457200" indent="-457200">
+              <a:lnSpc>
+                <a:spcPct val="150000"/>
+              </a:lnSpc>
               <a:buFont typeface="Arial" panose="020B0604020202020204" pitchFamily="34" charset="0"/>
               <a:buChar char="•"/>
             </a:pPr>
@@ -11376,6 +11403,9 @@
           </a:p>
           <a:p>
             <a:pPr marL="457200" indent="-457200">
+              <a:lnSpc>
+                <a:spcPct val="150000"/>
+              </a:lnSpc>
               <a:buFont typeface="Arial" panose="020B0604020202020204" pitchFamily="34" charset="0"/>
               <a:buChar char="•"/>
             </a:pPr>
@@ -11386,6 +11416,9 @@
           </a:p>
           <a:p>
             <a:pPr marL="457200" indent="-457200">
+              <a:lnSpc>
+                <a:spcPct val="150000"/>
+              </a:lnSpc>
               <a:buFont typeface="Arial" panose="020B0604020202020204" pitchFamily="34" charset="0"/>
               <a:buChar char="•"/>
             </a:pPr>
@@ -11395,6 +11428,11 @@
             </a:r>
           </a:p>
           <a:p>
+            <a:pPr>
+              <a:lnSpc>
+                <a:spcPct val="150000"/>
+              </a:lnSpc>
+            </a:pPr>
             <a:r>
               <a:rPr lang="pt-BR" sz="2000" dirty="0"/>
               <a:t>Exercícios recomendados:</a:t>
@@ -11402,6 +11440,9 @@
           </a:p>
           <a:p>
             <a:pPr marL="457178" indent="-457178">
+              <a:lnSpc>
+                <a:spcPct val="150000"/>
+              </a:lnSpc>
               <a:buFont typeface="Arial" panose="020B0604020202020204" pitchFamily="34" charset="0"/>
               <a:buChar char="•"/>
             </a:pPr>
@@ -11412,6 +11453,9 @@
           </a:p>
           <a:p>
             <a:pPr marL="457178" indent="-457178">
+              <a:lnSpc>
+                <a:spcPct val="150000"/>
+              </a:lnSpc>
               <a:buFont typeface="Arial" panose="020B0604020202020204" pitchFamily="34" charset="0"/>
               <a:buChar char="•"/>
             </a:pPr>
@@ -11636,7 +11680,7 @@
             <a:pPr lvl="1"/>
             <a:r>
               <a:rPr lang="pt-BR" sz="2800" dirty="0"/>
-              <a:t xml:space="preserve"> </a:t>
+              <a:t> </a:t>
             </a:r>
           </a:p>
           <a:p>
@@ -11886,7 +11930,7 @@
                 <a:pPr lvl="1"/>
                 <a:r>
                   <a:rPr lang="pt-BR" sz="2800" dirty="0"/>
-                  <a:t xml:space="preserve"> </a:t>
+                  <a:t> </a:t>
                 </a:r>
               </a:p>
               <a:p>
@@ -11906,7 +11950,7 @@
                 </a:pPr>
                 <a:r>
                   <a:rPr lang="pt-BR" sz="2800" dirty="0"/>
-                  <a:t xml:space="preserve">Quando as ocorrências pertencem a um intervalo em </a:t>
+                  <a:t>Quando as ocorrências pertencem a um intervalo em </a:t>
                 </a:r>
                 <a14:m>
                   <m:oMath xmlns:m="http://schemas.openxmlformats.org/officeDocument/2006/math">
@@ -12323,7 +12367,7 @@
         <p:spPr>
           <a:xfrm>
             <a:off x="650240" y="1493522"/>
-            <a:ext cx="11180365" cy="3108543"/>
+            <a:ext cx="11180365" cy="4549835"/>
           </a:xfrm>
           <a:prstGeom prst="rect">
             <a:avLst/>
@@ -12336,26 +12380,42 @@
           </a:bodyPr>
           <a:lstStyle/>
           <a:p>
+            <a:pPr>
+              <a:lnSpc>
+                <a:spcPct val="150000"/>
+              </a:lnSpc>
+            </a:pPr>
             <a:r>
               <a:rPr lang="pt-BR" sz="2800" b="1" dirty="0"/>
               <a:t>Distribuições de frequências</a:t>
             </a:r>
           </a:p>
           <a:p>
+            <a:pPr>
+              <a:lnSpc>
+                <a:spcPct val="150000"/>
+              </a:lnSpc>
+            </a:pPr>
             <a:endParaRPr lang="pt-BR" sz="2800" b="1" dirty="0"/>
           </a:p>
           <a:p>
             <a:pPr marL="457200" indent="-457200">
+              <a:lnSpc>
+                <a:spcPct val="150000"/>
+              </a:lnSpc>
               <a:buFont typeface="Arial" panose="020B0604020202020204" pitchFamily="34" charset="0"/>
               <a:buChar char="•"/>
             </a:pPr>
             <a:r>
               <a:rPr lang="pt-BR" sz="2800" dirty="0"/>
-              <a:t xml:space="preserve">Ao estudarmos uma variável, é importante saber a frequência que suas realizações acontecem. </a:t>
+              <a:t>Ao estudarmos uma variável, é importante saber a frequência que suas realizações acontecem. </a:t>
             </a:r>
           </a:p>
           <a:p>
             <a:pPr marL="457200" indent="-457200">
+              <a:lnSpc>
+                <a:spcPct val="150000"/>
+              </a:lnSpc>
               <a:buFont typeface="Arial" panose="020B0604020202020204" pitchFamily="34" charset="0"/>
               <a:buChar char="•"/>
             </a:pPr>
@@ -12363,6 +12423,9 @@
           </a:p>
           <a:p>
             <a:pPr marL="457200" indent="-457200">
+              <a:lnSpc>
+                <a:spcPct val="150000"/>
+              </a:lnSpc>
               <a:buFont typeface="Arial" panose="020B0604020202020204" pitchFamily="34" charset="0"/>
               <a:buChar char="•"/>
             </a:pPr>
@@ -12626,8 +12689,8 @@
           </a:prstGeom>
         </p:spPr>
       </p:pic>
-      <mc:AlternateContent xmlns:mc="http://schemas.openxmlformats.org/markup-compatibility/2006">
-        <mc:Choice xmlns:a14="http://schemas.microsoft.com/office/drawing/2010/main" Requires="a14">
+      <mc:AlternateContent xmlns:mc="http://schemas.openxmlformats.org/markup-compatibility/2006" xmlns:a14="http://schemas.microsoft.com/office/drawing/2010/main">
+        <mc:Choice Requires="a14">
           <p:sp>
             <p:nvSpPr>
               <p:cNvPr id="11" name="CaixaDeTexto 10">
@@ -12721,7 +12784,7 @@
                 </a:pPr>
                 <a:r>
                   <a:rPr lang="pt-BR" sz="2800" dirty="0"/>
-                  <a:t xml:space="preserve">Proporção </a:t>
+                  <a:t>Proporção </a:t>
                 </a:r>
                 <a14:m>
                   <m:oMath xmlns:m="http://schemas.openxmlformats.org/officeDocument/2006/math">
@@ -12820,10 +12883,11 @@
                 </a:pPr>
                 <a:r>
                   <a:rPr lang="pt-BR" sz="2800" dirty="0"/>
-                  <a:t xml:space="preserve">Porcentagem </a:t>
+                  <a:t>Porcentagem </a:t>
                 </a:r>
               </a:p>
               <a:p>
+                <a:pPr/>
                 <a14:m>
                   <m:oMathPara xmlns:m="http://schemas.openxmlformats.org/officeDocument/2006/math">
                     <m:oMathParaPr>
@@ -12881,7 +12945,7 @@
             </p:txBody>
           </p:sp>
         </mc:Choice>
-        <mc:Fallback>
+        <mc:Fallback xmlns="">
           <p:sp>
             <p:nvSpPr>
               <p:cNvPr id="11" name="CaixaDeTexto 10">

</xml_diff>

<commit_message>
Corrige rotulos de percentual da Figura 2.7 (Aula 1) que apareciam como 0% apos conversao para PDF
Bug de compatibilidade entre o rotulo de dado customizado do grafico e o LibreOffice, usado para gerar o PDF do site. Dado do grafico sempre esteve correto no .pptx; o rotulo agora usa texto literal em vez de referencia+formato numerico, robusto para as duas ferramentas.

Co-Authored-By: Claude Sonnet 5 <noreply@anthropic.com>
</commit_message>
<xml_diff>
--- a/content/2026-2/cea055-estatistica-probabilidade/01-estatistica-descritiva-i/Aula_01_Estatistica_Descritiva_I.pptx
+++ b/content/2026-2/cea055-estatistica-probabilidade/01-estatistica-descritiva-i/Aula_01_Estatistica_Descritiva_I.pptx
@@ -1038,17 +1038,24 @@
             <c:dLbl>
               <c:idx val="0"/>
               <c:tx>
-                <c:strRef>
-                  <c:f>Planilha1!$L$3</c:f>
-                  <c:strCache>
-                    <c:ptCount val="1"/>
-                    <c:pt idx="0">
-                      <c:v>27,78</c:v>
-                    </c:pt>
-                  </c:strCache>
-                </c:strRef>
+                <c:rich>
+                  <a:bodyPr/>
+                  <a:lstStyle/>
+                  <a:p>
+                    <a:r>
+                      <a:rPr lang="pt-BR" sz="1800">
+                        <a:solidFill>
+                          <a:schemeClr val="tx1">
+                            <a:lumMod val="75000"/>
+                            <a:lumOff val="25000"/>
+                          </a:schemeClr>
+                        </a:solidFill>
+                      </a:rPr>
+                      <a:t>27,78%</a:t>
+                    </a:r>
+                  </a:p>
+                </c:rich>
               </c:tx>
-              <c:numFmt formatCode="0&quot;%&quot;" sourceLinked="0"/>
               <c:spPr>
                 <a:noFill/>
                 <a:ln>
@@ -1086,7 +1093,7 @@
                 <c:ext xmlns:c15="http://schemas.microsoft.com/office/drawing/2012/chart" uri="{CE6537A1-D6FC-4f65-9D91-7224C49458BB}">
                   <c15:dlblFieldTable>
                     <c15:dlblFTEntry>
-                      <c15:txfldGUID>{3189E0D9-F10C-467C-8EBC-3B1762230742}</c15:txfldGUID>
+                      <c15:txfldGUID>{9BB0E77C-C640-4960-A8DD-290019CB0C55}</c15:txfldGUID>
                       <c15:f>Planilha1!$L$3</c15:f>
                       <c15:dlblFieldTableCache>
                         <c:ptCount val="1"/>
@@ -1106,17 +1113,24 @@
             <c:dLbl>
               <c:idx val="1"/>
               <c:tx>
-                <c:strRef>
-                  <c:f>Planilha1!$L$4</c:f>
-                  <c:strCache>
-                    <c:ptCount val="1"/>
-                    <c:pt idx="0">
-                      <c:v>33,33</c:v>
-                    </c:pt>
-                  </c:strCache>
-                </c:strRef>
+                <c:rich>
+                  <a:bodyPr/>
+                  <a:lstStyle/>
+                  <a:p>
+                    <a:r>
+                      <a:rPr lang="pt-BR" sz="1800">
+                        <a:solidFill>
+                          <a:schemeClr val="tx1">
+                            <a:lumMod val="75000"/>
+                            <a:lumOff val="25000"/>
+                          </a:schemeClr>
+                        </a:solidFill>
+                      </a:rPr>
+                      <a:t>33,33%</a:t>
+                    </a:r>
+                  </a:p>
+                </c:rich>
               </c:tx>
-              <c:numFmt formatCode="0&quot;%&quot;" sourceLinked="0"/>
               <c:spPr>
                 <a:noFill/>
                 <a:ln>
@@ -1154,7 +1168,7 @@
                 <c:ext xmlns:c15="http://schemas.microsoft.com/office/drawing/2012/chart" uri="{CE6537A1-D6FC-4f65-9D91-7224C49458BB}">
                   <c15:dlblFieldTable>
                     <c15:dlblFTEntry>
-                      <c15:txfldGUID>{51210F2C-8B52-4F7A-84DE-A1284C73A2D9}</c15:txfldGUID>
+                      <c15:txfldGUID>{A5B2F4DC-0742-48D4-B4CA-2172A0F59765}</c15:txfldGUID>
                       <c15:f>Planilha1!$L$4</c15:f>
                       <c15:dlblFieldTableCache>
                         <c:ptCount val="1"/>
@@ -1174,17 +1188,24 @@
             <c:dLbl>
               <c:idx val="2"/>
               <c:tx>
-                <c:strRef>
-                  <c:f>Planilha1!$L$5</c:f>
-                  <c:strCache>
-                    <c:ptCount val="1"/>
-                    <c:pt idx="0">
-                      <c:v>22,22</c:v>
-                    </c:pt>
-                  </c:strCache>
-                </c:strRef>
+                <c:rich>
+                  <a:bodyPr/>
+                  <a:lstStyle/>
+                  <a:p>
+                    <a:r>
+                      <a:rPr lang="pt-BR" sz="1800">
+                        <a:solidFill>
+                          <a:schemeClr val="tx1">
+                            <a:lumMod val="75000"/>
+                            <a:lumOff val="25000"/>
+                          </a:schemeClr>
+                        </a:solidFill>
+                      </a:rPr>
+                      <a:t>22,22%</a:t>
+                    </a:r>
+                  </a:p>
+                </c:rich>
               </c:tx>
-              <c:numFmt formatCode="0&quot;%&quot;" sourceLinked="0"/>
               <c:spPr>
                 <a:noFill/>
                 <a:ln>
@@ -1222,7 +1243,7 @@
                 <c:ext xmlns:c15="http://schemas.microsoft.com/office/drawing/2012/chart" uri="{CE6537A1-D6FC-4f65-9D91-7224C49458BB}">
                   <c15:dlblFieldTable>
                     <c15:dlblFTEntry>
-                      <c15:txfldGUID>{1CA8A19B-1A46-42B2-A8AB-FF6558229062}</c15:txfldGUID>
+                      <c15:txfldGUID>{2E11B46C-42CA-4222-9D7F-C451977FBD47}</c15:txfldGUID>
                       <c15:f>Planilha1!$L$5</c15:f>
                       <c15:dlblFieldTableCache>
                         <c:ptCount val="1"/>
@@ -1242,17 +1263,24 @@
             <c:dLbl>
               <c:idx val="3"/>
               <c:tx>
-                <c:strRef>
-                  <c:f>Planilha1!$L$6</c:f>
-                  <c:strCache>
-                    <c:ptCount val="1"/>
-                    <c:pt idx="0">
-                      <c:v>13,89</c:v>
-                    </c:pt>
-                  </c:strCache>
-                </c:strRef>
+                <c:rich>
+                  <a:bodyPr/>
+                  <a:lstStyle/>
+                  <a:p>
+                    <a:r>
+                      <a:rPr lang="pt-BR" sz="1800">
+                        <a:solidFill>
+                          <a:schemeClr val="tx1">
+                            <a:lumMod val="75000"/>
+                            <a:lumOff val="25000"/>
+                          </a:schemeClr>
+                        </a:solidFill>
+                      </a:rPr>
+                      <a:t>13,89%</a:t>
+                    </a:r>
+                  </a:p>
+                </c:rich>
               </c:tx>
-              <c:numFmt formatCode="0&quot;%&quot;" sourceLinked="0"/>
               <c:spPr>
                 <a:noFill/>
                 <a:ln>
@@ -1290,7 +1318,7 @@
                 <c:ext xmlns:c15="http://schemas.microsoft.com/office/drawing/2012/chart" uri="{CE6537A1-D6FC-4f65-9D91-7224C49458BB}">
                   <c15:dlblFieldTable>
                     <c15:dlblFTEntry>
-                      <c15:txfldGUID>{5CC83BDB-1898-463C-B5F6-253E6CA0BFEE}</c15:txfldGUID>
+                      <c15:txfldGUID>{E30A4D3E-B67D-4D1F-B73E-9237DE80372D}</c15:txfldGUID>
                       <c15:f>Planilha1!$L$6</c15:f>
                       <c15:dlblFieldTableCache>
                         <c:ptCount val="1"/>
@@ -1310,17 +1338,24 @@
             <c:dLbl>
               <c:idx val="4"/>
               <c:tx>
-                <c:strRef>
-                  <c:f>Planilha1!$L$7</c:f>
-                  <c:strCache>
-                    <c:ptCount val="1"/>
-                    <c:pt idx="0">
-                      <c:v>2,78</c:v>
-                    </c:pt>
-                  </c:strCache>
-                </c:strRef>
+                <c:rich>
+                  <a:bodyPr/>
+                  <a:lstStyle/>
+                  <a:p>
+                    <a:r>
+                      <a:rPr lang="pt-BR" sz="1800">
+                        <a:solidFill>
+                          <a:schemeClr val="tx1">
+                            <a:lumMod val="75000"/>
+                            <a:lumOff val="25000"/>
+                          </a:schemeClr>
+                        </a:solidFill>
+                      </a:rPr>
+                      <a:t>2,78%</a:t>
+                    </a:r>
+                  </a:p>
+                </c:rich>
               </c:tx>
-              <c:numFmt formatCode="0&quot;%&quot;" sourceLinked="0"/>
               <c:spPr>
                 <a:noFill/>
                 <a:ln>
@@ -1358,7 +1393,7 @@
                 <c:ext xmlns:c15="http://schemas.microsoft.com/office/drawing/2012/chart" uri="{CE6537A1-D6FC-4f65-9D91-7224C49458BB}">
                   <c15:dlblFieldTable>
                     <c15:dlblFTEntry>
-                      <c15:txfldGUID>{2CD63BDD-1A4A-4C5F-9B93-06E7E6F76D24}</c15:txfldGUID>
+                      <c15:txfldGUID>{4C758184-E731-45DF-8733-2179A3402C36}</c15:txfldGUID>
                       <c15:f>Planilha1!$L$7</c15:f>
                       <c15:dlblFieldTableCache>
                         <c:ptCount val="1"/>
@@ -12995,7 +13030,7 @@
             </a:r>
             <a:r>
               <a:rPr lang="pt-BR" sz="2800" dirty="0"/>
-              <a:t>no gráfico de barras comum, as barras têm largura igual e representam categorias (dados qualitativos); no histograma, </a:t>
+              <a:t>no gráfico de barras comum, as barras têm largura igual e representam categorias (dados qualitativos); </a:t>
             </a:r>
           </a:p>
         </p:txBody>
@@ -13276,8 +13311,8 @@
           <a:chExt cx="0" cy="0"/>
         </a:xfrm>
       </p:grpSpPr>
-      <mc:AlternateContent xmlns:mc="http://schemas.openxmlformats.org/markup-compatibility/2006">
-        <mc:Choice xmlns:a14="http://schemas.microsoft.com/office/drawing/2010/main" Requires="a14">
+      <mc:AlternateContent xmlns:mc="http://schemas.openxmlformats.org/markup-compatibility/2006" xmlns:a14="http://schemas.microsoft.com/office/drawing/2010/main">
+        <mc:Choice Requires="a14">
           <p:sp>
             <p:nvSpPr>
               <p:cNvPr id="6" name="CaixaDeTexto 5">
@@ -13498,7 +13533,7 @@
             </p:txBody>
           </p:sp>
         </mc:Choice>
-        <mc:Fallback>
+        <mc:Fallback xmlns="">
           <p:sp>
             <p:nvSpPr>
               <p:cNvPr id="6" name="CaixaDeTexto 5">
@@ -25603,8 +25638,8 @@
           <a:chExt cx="0" cy="0"/>
         </a:xfrm>
       </p:grpSpPr>
-      <mc:AlternateContent xmlns:mc="http://schemas.openxmlformats.org/markup-compatibility/2006">
-        <mc:Choice xmlns:a14="http://schemas.microsoft.com/office/drawing/2010/main" Requires="a14">
+      <mc:AlternateContent xmlns:mc="http://schemas.openxmlformats.org/markup-compatibility/2006" xmlns:a14="http://schemas.microsoft.com/office/drawing/2010/main">
+        <mc:Choice Requires="a14">
           <p:sp>
             <p:nvSpPr>
               <p:cNvPr id="6" name="CaixaDeTexto 5">
@@ -25745,7 +25780,7 @@
             </p:txBody>
           </p:sp>
         </mc:Choice>
-        <mc:Fallback>
+        <mc:Fallback xmlns="">
           <p:sp>
             <p:nvSpPr>
               <p:cNvPr id="6" name="CaixaDeTexto 5">
@@ -25872,7 +25907,7 @@
             <p:spPr>
               <a:xfrm>
                 <a:off x="636988" y="596963"/>
-                <a:ext cx="11180365" cy="4673844"/>
+                <a:ext cx="11180365" cy="4721036"/>
               </a:xfrm>
               <a:prstGeom prst="rect">
                 <a:avLst/>
@@ -26344,7 +26379,7 @@
                                 <a:rPr lang="pt-BR" sz="2800" b="0" i="1" smtClean="0">
                                   <a:latin typeface="Cambria Math" panose="02040503050406030204" pitchFamily="18" charset="0"/>
                                 </a:rPr>
-                                <m:t>𝑘</m:t>
+                                <m:t>𝑗</m:t>
                               </m:r>
                             </m:sub>
                           </m:sSub>
@@ -26369,7 +26404,7 @@
                                 <a:rPr lang="pt-BR" sz="2800" b="0" i="1" smtClean="0">
                                   <a:latin typeface="Cambria Math" panose="02040503050406030204" pitchFamily="18" charset="0"/>
                                 </a:rPr>
-                                <m:t>𝑘</m:t>
+                                <m:t>𝑗</m:t>
                               </m:r>
                             </m:sub>
                           </m:sSub>
@@ -26383,6 +26418,30 @@
                           </m:r>
                         </m:den>
                       </m:f>
+                      <m:r>
+                        <a:rPr lang="pt-BR" sz="2800" b="0" i="1" smtClean="0">
+                          <a:latin typeface="Cambria Math" panose="02040503050406030204" pitchFamily="18" charset="0"/>
+                        </a:rPr>
+                        <m:t>,  </m:t>
+                      </m:r>
+                      <m:r>
+                        <a:rPr lang="pt-BR" sz="2800" b="0" i="1" smtClean="0">
+                          <a:latin typeface="Cambria Math" panose="02040503050406030204" pitchFamily="18" charset="0"/>
+                        </a:rPr>
+                        <m:t>𝑗</m:t>
+                      </m:r>
+                      <m:r>
+                        <a:rPr lang="pt-BR" sz="2800" b="0" i="1" smtClean="0">
+                          <a:latin typeface="Cambria Math" panose="02040503050406030204" pitchFamily="18" charset="0"/>
+                        </a:rPr>
+                        <m:t>≤</m:t>
+                      </m:r>
+                      <m:r>
+                        <a:rPr lang="pt-BR" sz="2800" b="0" i="1" smtClean="0">
+                          <a:latin typeface="Cambria Math" panose="02040503050406030204" pitchFamily="18" charset="0"/>
+                        </a:rPr>
+                        <m:t>𝑘</m:t>
+                      </m:r>
                       <m:r>
                         <a:rPr lang="pt-BR" sz="2800" b="0" i="1" smtClean="0">
                           <a:latin typeface="Cambria Math" panose="02040503050406030204" pitchFamily="18" charset="0"/>
@@ -26624,10 +26683,10 @@
                         </m:e>
                         <m:sub>
                           <m:r>
-                            <a:rPr lang="pt-BR" sz="2800" i="1">
+                            <a:rPr lang="pt-BR" sz="2800" b="0" i="1" smtClean="0">
                               <a:latin typeface="Cambria Math" panose="02040503050406030204" pitchFamily="18" charset="0"/>
                             </a:rPr>
-                            <m:t>𝑘</m:t>
+                            <m:t>𝑗</m:t>
                           </m:r>
                         </m:sub>
                       </m:sSub>
@@ -26649,13 +26708,43 @@
                         </m:e>
                         <m:sub>
                           <m:r>
-                            <a:rPr lang="pt-BR" sz="2800" i="1">
+                            <a:rPr lang="pt-BR" sz="2800" b="0" i="1" smtClean="0">
                               <a:latin typeface="Cambria Math" panose="02040503050406030204" pitchFamily="18" charset="0"/>
                             </a:rPr>
-                            <m:t>𝑘</m:t>
+                            <m:t>𝑗</m:t>
                           </m:r>
                         </m:sub>
                       </m:sSub>
+                      <m:r>
+                        <a:rPr lang="pt-BR" sz="2800" i="1">
+                          <a:latin typeface="Cambria Math" panose="02040503050406030204" pitchFamily="18" charset="0"/>
+                        </a:rPr>
+                        <m:t>,</m:t>
+                      </m:r>
+                      <m:r>
+                        <a:rPr lang="pt-BR" sz="2800" b="0" i="1" smtClean="0">
+                          <a:latin typeface="Cambria Math" panose="02040503050406030204" pitchFamily="18" charset="0"/>
+                        </a:rPr>
+                        <m:t>  </m:t>
+                      </m:r>
+                      <m:r>
+                        <a:rPr lang="pt-BR" sz="2800" i="1">
+                          <a:latin typeface="Cambria Math" panose="02040503050406030204" pitchFamily="18" charset="0"/>
+                        </a:rPr>
+                        <m:t>𝑗</m:t>
+                      </m:r>
+                      <m:r>
+                        <a:rPr lang="pt-BR" sz="2800" i="1">
+                          <a:latin typeface="Cambria Math" panose="02040503050406030204" pitchFamily="18" charset="0"/>
+                        </a:rPr>
+                        <m:t>≤</m:t>
+                      </m:r>
+                      <m:r>
+                        <a:rPr lang="pt-BR" sz="2800" i="1">
+                          <a:latin typeface="Cambria Math" panose="02040503050406030204" pitchFamily="18" charset="0"/>
+                        </a:rPr>
+                        <m:t>𝑘</m:t>
+                      </m:r>
                       <m:r>
                         <a:rPr lang="pt-BR" sz="2800" b="0" i="1" smtClean="0">
                           <a:latin typeface="Cambria Math" panose="02040503050406030204" pitchFamily="18" charset="0"/>
@@ -26749,7 +26838,7 @@
             <p:spPr>
               <a:xfrm>
                 <a:off x="636988" y="596963"/>
-                <a:ext cx="11180365" cy="4673844"/>
+                <a:ext cx="11180365" cy="4721036"/>
               </a:xfrm>
               <a:prstGeom prst="rect">
                 <a:avLst/>
@@ -26757,7 +26846,7 @@
               <a:blipFill>
                 <a:blip r:embed="rId2"/>
                 <a:stretch>
-                  <a:fillRect l="-1090" t="-1304"/>
+                  <a:fillRect l="-1090" t="-1292"/>
                 </a:stretch>
               </a:blipFill>
             </p:spPr>
@@ -26841,8 +26930,8 @@
           <a:chExt cx="0" cy="0"/>
         </a:xfrm>
       </p:grpSpPr>
-      <mc:AlternateContent xmlns:mc="http://schemas.openxmlformats.org/markup-compatibility/2006">
-        <mc:Choice xmlns:a14="http://schemas.microsoft.com/office/drawing/2010/main" Requires="a14">
+      <mc:AlternateContent xmlns:mc="http://schemas.openxmlformats.org/markup-compatibility/2006" xmlns:a14="http://schemas.microsoft.com/office/drawing/2010/main">
+        <mc:Choice Requires="a14">
           <p:sp>
             <p:nvSpPr>
               <p:cNvPr id="6" name="CaixaDeTexto 5">
@@ -27517,7 +27606,7 @@
             </p:txBody>
           </p:sp>
         </mc:Choice>
-        <mc:Fallback>
+        <mc:Fallback xmlns="">
           <p:sp>
             <p:nvSpPr>
               <p:cNvPr id="6" name="CaixaDeTexto 5">
@@ -27814,8 +27903,8 @@
           <a:chExt cx="0" cy="0"/>
         </a:xfrm>
       </p:grpSpPr>
-      <mc:AlternateContent xmlns:mc="http://schemas.openxmlformats.org/markup-compatibility/2006">
-        <mc:Choice xmlns:a14="http://schemas.microsoft.com/office/drawing/2010/main" Requires="a14">
+      <mc:AlternateContent xmlns:mc="http://schemas.openxmlformats.org/markup-compatibility/2006" xmlns:a14="http://schemas.microsoft.com/office/drawing/2010/main">
+        <mc:Choice Requires="a14">
           <p:sp>
             <p:nvSpPr>
               <p:cNvPr id="6" name="CaixaDeTexto 5">
@@ -27992,7 +28081,7 @@
             </p:txBody>
           </p:sp>
         </mc:Choice>
-        <mc:Fallback>
+        <mc:Fallback xmlns="">
           <p:sp>
             <p:nvSpPr>
               <p:cNvPr id="6" name="CaixaDeTexto 5">
@@ -28400,8 +28489,8 @@
           <a:chExt cx="0" cy="0"/>
         </a:xfrm>
       </p:grpSpPr>
-      <mc:AlternateContent xmlns:mc="http://schemas.openxmlformats.org/markup-compatibility/2006">
-        <mc:Choice xmlns:a14="http://schemas.microsoft.com/office/drawing/2010/main" Requires="a14">
+      <mc:AlternateContent xmlns:mc="http://schemas.openxmlformats.org/markup-compatibility/2006" xmlns:a14="http://schemas.microsoft.com/office/drawing/2010/main">
+        <mc:Choice Requires="a14">
           <p:sp>
             <p:nvSpPr>
               <p:cNvPr id="6" name="CaixaDeTexto 5">
@@ -28509,7 +28598,7 @@
             </p:txBody>
           </p:sp>
         </mc:Choice>
-        <mc:Fallback>
+        <mc:Fallback xmlns="">
           <p:sp>
             <p:nvSpPr>
               <p:cNvPr id="6" name="CaixaDeTexto 5">
@@ -28750,8 +28839,8 @@
           <a:chExt cx="0" cy="0"/>
         </a:xfrm>
       </p:grpSpPr>
-      <mc:AlternateContent xmlns:mc="http://schemas.openxmlformats.org/markup-compatibility/2006">
-        <mc:Choice xmlns:a14="http://schemas.microsoft.com/office/drawing/2010/main" Requires="a14">
+      <mc:AlternateContent xmlns:mc="http://schemas.openxmlformats.org/markup-compatibility/2006" xmlns:a14="http://schemas.microsoft.com/office/drawing/2010/main">
+        <mc:Choice Requires="a14">
           <p:sp>
             <p:nvSpPr>
               <p:cNvPr id="6" name="CaixaDeTexto 5">
@@ -29003,7 +29092,7 @@
             </p:txBody>
           </p:sp>
         </mc:Choice>
-        <mc:Fallback>
+        <mc:Fallback xmlns="">
           <p:sp>
             <p:nvSpPr>
               <p:cNvPr id="6" name="CaixaDeTexto 5">

</xml_diff>